<commit_message>
Deck v3: refreshed figures embedded, C17 final verdict in, g6 slide added
All six rebuilt figures re-embedded (the deck carried stale copies with the
collisions and the CN-9 error). New slide 7 'From structure to a number' uses
g6_vector, closing the gap between 'what the model is' and 'the results'.
Slide 12's objective column now carries the FINAL pre-registered C17 numbers
(dist +0.0189 p=0.006, simplicial +0.0165 p=0.003, both n=32, both passing the
scale-free check) replacing the 24-seed interim and the 'campaign completing
tonight' note. Slide 8's notes state the ensemble nuance honestly: the
simplicial ensemble moves 0.239->0.243 with the new weight while the best
single 3D arm remains the distance encoder at 0.266. Summary claim 3 now cites
the fully pre-registered transfer as the project's cleanest positive.

Co-Authored-By: Claude Opus 5 <noreply@anthropic.com>
</commit_message>
<xml_diff>
--- a/docs/vogiatzis_condensed_2026-08.pptx
+++ b/docs/vogiatzis_condensed_2026-08.pptx
@@ -17,6 +17,7 @@
     <p:sldId id="265" r:id="rId17"/>
     <p:sldId id="266" r:id="rId18"/>
     <p:sldId id="267" r:id="rId19"/>
+    <p:sldId id="268" r:id="rId20"/>
   </p:sldIdLst>
   <p:sldSz cx="12191695" cy="6858000" type="screen4x3"/>
   <p:notesSz cx="6858000" cy="9144000"/>
@@ -513,7 +514,7 @@
           <a:lstStyle/>
           <a:p>
             <a:r>
-              <a:t>First full walkthrough for Kostas. Order: problem, data, how models are tested, what the 3D model is, results, why the 3D signal is capped, the chemistry benchmark, what actually moves the score, next steps.</a:t>
+              <a:t>Order: problem, data, evaluation, the 3D model + how it predicts, results, why capped, the chemistry benchmark, what moves the score, summary.</a:t>
             </a:r>
           </a:p>
         </p:txBody>
@@ -583,7 +584,7 @@
           <a:lstStyle/>
           <a:p>
             <a:r>
-              <a:t>Population version of the previous slide: one dot per ligand. GFN2 mean 0.41 — the bond shrinks 2.5x too little — and scatter is mostly noise (only 23% of its ligand-to-ligand variation reproduces; 96% for g-xTB). g-xTB (Grimme group 2025, f-electrons explicit) improves 71 of 71 ligands, p = 5e-52; replicated in solvent. Why this is new: published benchmarks asked 'are the bond lengths of individual complexes close to DFT or X-ray?' (Bursch 2017: 80 complexes vs X-ray; Zhang 2026: vs DFT). Nobody asked 'walking La-&gt;Lu inside one ligand, does the bond shrink by the RIGHT AMOUNT vs experiment?' — a systematic trend error that per-complex statistics cannot see. And g-xTB's own preprint validates energies only, so its lanthanide geometries were untested until now. Obligation: read the Ln-xTB paper in full and run it through this same benchmark.</a:t>
+              <a:t>Define the observable: fixed ligand cage, swap the metal, re-relax, bond vs experimental radius; slope 1 = tracks reality. Inset: one adjacent step (Tb-Gd, 13 mA) -&gt; 5 mA response under GFN2 vs 15 mA under g-xTB — the physical signal an adjacent pair rides on, ~3x. This ligand is CN 8; fits use CN 8 radii.</a:t>
             </a:r>
           </a:p>
         </p:txBody>
@@ -653,7 +654,7 @@
           <a:lstStyle/>
           <a:p>
             <a:r>
-              <a:t>The decisive experiment: re-optimise all 956 complexes with g-xTB (structures now carry correct contraction physics), retrain everything matched — score does not move (+0.004). Cleaning conformer noise 455x: slightly worse. So structure quality is not the bottleneck. What did pay, every time: aligning the training loss with the scored quantity — the quantile loss on the trees (+0.136 cumulative) and up-weighting the within-block contrast term for the 3D model (+0.014-0.015, replicated on two different architectures with disjoint random seeds). Ceiling: repeated measurements of the same separation agree to 0.153 on a spread of 0.224 -&gt; labels support R2 ~ 0.53; we are at 0.31. The rest is likely in conditions and in predicting pairs directly — not in geometry (~1% of pair variance).</a:t>
+              <a:t>Population version: GFN2 mean 0.41, mostly noise (23% cross-ligand reproducibility vs 96%); g-xTB 1.08, improving 71/71 ligands, p=5e-52; replicated in solvent. Novelty (web-checked): prior work scored per-complex bond errors vs DFT/X-ray (Bursch 2017; Ln-xTB 2026); the response slope vs EXPERIMENT had not been measured, and g-xTB had no lanthanide geometry validation at all. Obligation: read Ln-xTB in full; run it through this benchmark.</a:t>
             </a:r>
           </a:p>
         </p:txBody>
@@ -723,7 +724,77 @@
           <a:lstStyle/>
           <a:p>
             <a:r>
-              <a:t>Suggested call order: S2 (2 min), S7 (5), S8-S10 (10), S11 (3), discussion. If he asks for the one-sentence version: the 3D model earns its place by correcting shared errors, the chemistry that limits it is now measured and publishable on its own, and the cheapest reliable gains were loss-function alignment.</a:t>
+              <a:t>Decisive: re-optimise all 956 complexes with g-xTB, retrain matched: +0.004 n.s. Cleaning conformer noise 455x: worse. Conditions into the representation: -0.108. What paid: quantile loss on trees (+0.136 cumulative) and the contrast weight 2-&gt;4 — final, pre-registered, both encoders, disjoint seeds, n=32 each: dist +0.0189 p=0.006, simplicial +0.0165 p=0.003, BOTH passing the scale-free anti-calibration check. Ceiling: separations reproduce to 0.153 on 0.224 spread -&gt; ~0.53; we are at 0.31; geometry ~1% of pair variance.</a:t>
+            </a:r>
+          </a:p>
+        </p:txBody>
+      </p:sp>
+      <p:sp>
+        <p:nvSpPr>
+          <p:cNvPr id="4" name="Slide Number Placeholder 3"/>
+          <p:cNvSpPr>
+            <a:spLocks noGrp="1"/>
+          </p:cNvSpPr>
+          <p:nvPr>
+            <p:ph type="sldNum" idx="5" sz="quarter"/>
+          </p:nvPr>
+        </p:nvSpPr>
+        <p:spPr/>
+      </p:sp>
+    </p:spTree>
+  </p:cSld>
+  <p:clrMapOvr>
+    <a:masterClrMapping/>
+  </p:clrMapOvr>
+</p:notes>
+</file>
+
+<file path=ppt/notesSlides/notesSlide13.xml><?xml version="1.0" encoding="utf-8"?>
+<p:notes xmlns:a="http://schemas.openxmlformats.org/drawingml/2006/main" xmlns:p="http://schemas.openxmlformats.org/presentationml/2006/main" xmlns:r="http://schemas.openxmlformats.org/officeDocument/2006/relationships">
+  <p:cSld>
+    <p:spTree>
+      <p:nvGrpSpPr>
+        <p:cNvPr id="1" name=""/>
+        <p:cNvGrpSpPr/>
+        <p:nvPr/>
+      </p:nvGrpSpPr>
+      <p:grpSpPr>
+        <a:xfrm>
+          <a:off x="0" y="0"/>
+          <a:ext cx="0" cy="0"/>
+          <a:chOff x="0" y="0"/>
+          <a:chExt cx="0" cy="0"/>
+        </a:xfrm>
+      </p:grpSpPr>
+      <p:sp>
+        <p:nvSpPr>
+          <p:cNvPr id="2" name="Slide Image Placeholder 1"/>
+          <p:cNvSpPr>
+            <a:spLocks noGrp="1"/>
+          </p:cNvSpPr>
+          <p:nvPr>
+            <p:ph type="sldImg" idx="2"/>
+          </p:nvPr>
+        </p:nvSpPr>
+        <p:spPr/>
+      </p:sp>
+      <p:sp>
+        <p:nvSpPr>
+          <p:cNvPr id="3" name="Notes Placeholder 2"/>
+          <p:cNvSpPr>
+            <a:spLocks noGrp="1"/>
+          </p:cNvSpPr>
+          <p:nvPr>
+            <p:ph type="body" idx="3" sz="quarter"/>
+          </p:nvPr>
+        </p:nvSpPr>
+        <p:spPr/>
+        <p:txBody>
+          <a:bodyPr/>
+          <a:lstStyle/>
+          <a:p>
+            <a:r>
+              <a:t>If time is short: S8 and S11 are the talk. Call order suggestion: S2 (2 min), S8 (5), S9-S11 (10), S12 (3), discussion.</a:t>
             </a:r>
           </a:p>
         </p:txBody>
@@ -793,7 +864,7 @@
           <a:lstStyle/>
           <a:p>
             <a:r>
-              <a:t>Industrial framing: solvent extraction is the route; adjacent pairs (Nd/Pr for magnets, Dy/Tb) are the expensive ones. The schematic defines the exact predicted quantity — walk it slowly. R2 = 0 means predicting the average separation for every pair; even the sign of the separation is nontrivial (best models reach 67% sign accuracy).</a:t>
+              <a:t>Adjacent pairs (Nd/Pr, Dy/Tb) are the expensive separations. The schematic defines the predicted quantity. R2=0 already means predicting the average separation; best sign accuracy ~0.67.</a:t>
             </a:r>
           </a:p>
         </p:txBody>
@@ -863,7 +934,7 @@
           <a:lstStyle/>
           <a:p>
             <a:r>
-              <a:t>SAFE is DOI-linked and condition-resolved; replicates across labs are real replicates (later this gives the noise floor). Pm does not occur in nature -&gt; 14 lanthanides. Architector builds a 3D guess of the actual extraction complex; GFN2-xTB relaxes it; convergence is verified with an independent force check. 956 unique complexes back 4,746 measurements.</a:t>
+              <a:t>SAFE: DOI-linked, condition-resolved; replicates across labs are real replicates (later gives the noise floor). 956 complexes; convergence force-checked independently.</a:t>
             </a:r>
           </a:p>
         </p:txBody>
@@ -933,7 +1004,7 @@
           <a:lstStyle/>
           <a:p>
             <a:r>
-              <a:t>Why grouped: extractants repeat across rows; a random row split would let the model memorise the ligand — leakage. Why repeats: one grouping is one lottery draw. Why ensembles/seeds: single networks are noisy; per-seed sd of a paired difference is 0.0285, so confirmatory comparisons use 24-32 seeds. Out-of-fold = the union of held-out predictions.</a:t>
+              <a:t>Grouped CV = no ligand leakage; replicate averaging inside blocks; ensembles scored out-of-fold. Step 2 walks a real TODGA block: the +1.6 offset on an unseen extractant cancels in the difference — why the metric differences within blocks. Per-seed sd of a paired delta 0.0285 -&gt; confirmatory runs use 24-32 seeds.</a:t>
             </a:r>
           </a:p>
         </p:txBody>
@@ -1003,7 +1074,7 @@
           <a:lstStyle/>
           <a:p>
             <a:r>
-              <a:t>Two conventional ('2D': they see the molecular graph and conditions, no 3D structure): gradient-boosted trees on the 746 columns; a neural network on fingerprints. The third is ours and is introduced properly on the next slide. All three predict log D per row; separations come from differencing predictions within a block. A combination fits per-extractant weights over the three predictions, on the separation vectors themselves (nested, held-out).</a:t>
+              <a:t>Two conventional (no 3D input): boosted trees on 746 columns; fingerprint network. Third reads the optimised 3D structure (next two slides). Combination = per-extractant NNLS on the separation vectors, nested.</a:t>
             </a:r>
           </a:p>
         </p:txBody>
@@ -1073,7 +1144,7 @@
           <a:lstStyle/>
           <a:p>
             <a:r>
-              <a:t>Vietoris-Rips = the mesh built by rule 2+3; message passing = each atom repeatedly updates its state from its neighbours along edges and triangles; after 3 rounds each atom has 'seen' its 3-hop environment. Pooling is metal-centred: a soft histogram of distances to the metal — plain averaging over ~100 atoms would wash out the 0.01-A shell changes that carry the signal. Without that pooling the model cannot even tell which lanthanide it holds.</a:t>
+              <a:t>Panels are a REAL Dy complex from the shipped asset: its true 96 edges and 147 triangles at the 3.5 A training radius. Message passing: one donor's incoming messages highlighted. Readout is metal-centred by distance shell — without it the encoder cannot even identify the lanthanide (R2 0.016).</a:t>
             </a:r>
           </a:p>
         </p:txBody>
@@ -1143,7 +1214,7 @@
           <a:lstStyle/>
           <a:p>
             <a:r>
-              <a:t>Loss functions mattered more than architectures: the tree model at RMSE scores 0.14; switching to a quantile loss and re-tuning gives 0.278. The 3D model's contrast-weighted loss gives 0.266. Control row: giving the tree model 84 3D-derived tabular descriptors (donor distances, angles, charges) makes it WORSE (-0.02) — so the 3D model's contribution is not replicable by cheap descriptors; in the combination the fitted weight on the 3D model is the largest (0.46). Caveats aloud: under stricter condition blocking the 3D margin halves to +0.010; the 0.313 is exploratory — all clean held-out partitions have been consumed; a fresh split is the next step before any publication-grade claim.</a:t>
+              <a:t>One real Gd/TODGA row, end to end: the actual 864-number embedding (9 named readout blocks), the row's 746 tabular values, concatenate 1610, the real head, the model's real held-out prediction (+0.95 vs measured +2.42 — absolute log D of an unseen extractant is hard; differences are what is scored). Loss card: per-row Huber + within-block pair term (weight 2, adjacent x3) — term 2 is why it learns separations; the next slides change exactly that weight.</a:t>
             </a:r>
           </a:p>
         </p:txBody>
@@ -1213,7 +1284,7 @@
           <a:lstStyle/>
           <a:p>
             <a:r>
-              <a:t>Walk the figure: these are the method's own published parameters, plotted against atomic number. Every lanthanide between Ce and Lu was never fitted — it is the straight line. f-electrons are frozen into the core. So to this method, 'which lanthanide' is a single number that slides along a line. Consequence for ML: any structure it produces can encode the metal only through that one number — and we already give the models that number as a column (the experimental ionic radius). Empirical check: we trained eight different 3D architectures; their predictions are statistically identical (correlation 0.986 across architectures = the seed-to-seed correlation of one architecture).</a:t>
+              <a:t>Loss functions matter more than architectures. Rows: trees 0.278 (RMSE-&gt;quantile + re-tune; +0.016 confirmed held-out); fingerprint 0.221; best single 3D arm 0.266 (distance encoder with the new contrast weight; the simplicial ensemble is 0.239-&gt;0.243 with it); 2D stack 0.291; +3D 0.313, marginal +0.023, largest weight 0.46. Control row: same trees + 84 3D-derived descriptor columns COLLAPSES to -0.02 -&gt; the encoder is not replicable by cheap descriptors; over that stack its marginal is +0.041. Caveats aloud: strict key +0.010; 0.313 exploratory (no clean held-out partition remains -&gt; fresh split next).</a:t>
             </a:r>
           </a:p>
         </p:txBody>
@@ -1283,7 +1354,7 @@
           <a:lstStyle/>
           <a:p>
             <a:r>
-              <a:t>Define the observable slowly — it is ours. Take ONE ligand cage, keep it fixed, put each of the 14 lanthanides in, re-relax, measure the mean metal-donor distance, plot against the EXPERIMENTAL radius of that ion. Slope 1.00 = the bond tracks reality. This isolates exactly the physics adjacent-pair selectivity depends on. The figure is one real ligand of the 71 measured; both methods run through the identical protocol, same binary.</a:t>
+              <a:t>The method's own parameters vs Z: every lanthanide between the two circled anchors IS the straight line — panel 4 proves it for all 16 parameter families (deviations = the file's rounding). Grey band at Gd = where a real f-shell puts a break; GFN2 cannot, by construction. Empirical consequence already measured: eight 3D encoders statistically identical (r 0.986 = seed noise). The one number the geometry can carry is already a descriptor column.</a:t>
             </a:r>
           </a:p>
         </p:txBody>
@@ -4405,6 +4476,83 @@
               </a:defRPr>
             </a:pPr>
             <a:r>
+              <a:t>Measuring what the structures get wrong: the contraction response</a:t>
+            </a:r>
+          </a:p>
+        </p:txBody>
+      </p:sp>
+      <p:pic>
+        <p:nvPicPr>
+          <p:cNvPr id="3" name="Picture 2" descr="g5_slope_demo.png"/>
+          <p:cNvPicPr>
+            <a:picLocks noChangeAspect="1"/>
+          </p:cNvPicPr>
+          <p:nvPr/>
+        </p:nvPicPr>
+        <p:blipFill>
+          <a:blip r:embed="rId3"/>
+          <a:stretch>
+            <a:fillRect/>
+          </a:stretch>
+        </p:blipFill>
+        <p:spPr>
+          <a:xfrm>
+            <a:off x="1798167" y="1280160"/>
+            <a:ext cx="8595360" cy="4721335"/>
+          </a:xfrm>
+          <a:prstGeom prst="rect">
+            <a:avLst/>
+          </a:prstGeom>
+        </p:spPr>
+      </p:pic>
+    </p:spTree>
+  </p:cSld>
+  <p:clrMapOvr>
+    <a:masterClrMapping/>
+  </p:clrMapOvr>
+</p:sld>
+</file>
+
+<file path=ppt/slides/slide11.xml><?xml version="1.0" encoding="utf-8"?>
+<p:sld xmlns:a="http://schemas.openxmlformats.org/drawingml/2006/main" xmlns:p="http://schemas.openxmlformats.org/presentationml/2006/main" xmlns:r="http://schemas.openxmlformats.org/officeDocument/2006/relationships">
+  <p:cSld>
+    <p:spTree>
+      <p:nvGrpSpPr>
+        <p:cNvPr id="1" name=""/>
+        <p:cNvGrpSpPr/>
+        <p:nvPr/>
+      </p:nvGrpSpPr>
+      <p:grpSpPr/>
+      <p:sp>
+        <p:nvSpPr>
+          <p:cNvPr id="2" name="TextBox 1"/>
+          <p:cNvSpPr txBox="1"/>
+          <p:nvPr/>
+        </p:nvSpPr>
+        <p:spPr>
+          <a:xfrm>
+            <a:off x="502920" y="292608"/>
+            <a:ext cx="11247120" cy="640080"/>
+          </a:xfrm>
+          <a:prstGeom prst="rect">
+            <a:avLst/>
+          </a:prstGeom>
+          <a:noFill/>
+        </p:spPr>
+        <p:txBody>
+          <a:bodyPr wrap="none">
+            <a:spAutoFit/>
+          </a:bodyPr>
+          <a:lstStyle/>
+          <a:p>
+            <a:pPr>
+              <a:defRPr sz="2600" b="1">
+                <a:solidFill>
+                  <a:srgbClr val="1A2E4A"/>
+                </a:solidFill>
+              </a:defRPr>
+            </a:pPr>
+            <a:r>
               <a:t>Across 71 ligands: GFN2-xTB under-responds 2.5×; g-xTB gets it right</a:t>
             </a:r>
           </a:p>
@@ -4467,7 +4615,7 @@
               </a:defRPr>
             </a:pPr>
             <a:r>
-              <a:t>New in this measurement: published benchmarks score individual complexes against DFT or X-ray structures. The response to the contraction — the trend across the series, against experimental radii — had not been measured for any tight-binding method, and g-xTB's lanthanide geometries had never been tested at all (its paper validates energies).</a:t>
+              <a:t>New in this measurement: published benchmarks score individual complexes against DFT or X-ray. The response to the contraction — the trend across the series, against experimental radii — had not been measured for any tight-binding method, and g-xTB's lanthanide geometries had never been tested (its paper validates energies).</a:t>
             </a:r>
           </a:p>
         </p:txBody>
@@ -4480,7 +4628,7 @@
 </p:sld>
 </file>
 
-<file path=ppt/slides/slide11.xml><?xml version="1.0" encoding="utf-8"?>
+<file path=ppt/slides/slide12.xml><?xml version="1.0" encoding="utf-8"?>
 <p:sld xmlns:a="http://schemas.openxmlformats.org/drawingml/2006/main" xmlns:p="http://schemas.openxmlformats.org/presentationml/2006/main" xmlns:r="http://schemas.openxmlformats.org/officeDocument/2006/relationships">
   <p:cSld>
     <p:spTree>
@@ -4544,10 +4692,10 @@
                 <a:tableStyleId>{5C22544A-7EE6-4342-B048-85BDC9FD1C3A}</a:tableStyleId>
               </a:tblPr>
               <a:tblGrid>
-                <a:gridCol w="4297680"/>
+                <a:gridCol w="4206240"/>
                 <a:gridCol w="1371600"/>
                 <a:gridCol w="3840480"/>
-                <a:gridCol w="1371600"/>
+                <a:gridCol w="1463040"/>
               </a:tblGrid>
               <a:tr h="333756">
                 <a:tc>
@@ -4729,7 +4877,7 @@
                         <a:defRPr sz="1300"/>
                       </a:pPr>
                       <a:r>
-                        <a:t>3D model: up-weight the contrast term</a:t>
+                        <a:t>contrast weight 2→4, distance encoder (32 seeds)</a:t>
                       </a:r>
                     </a:p>
                   </a:txBody>
@@ -4744,7 +4892,7 @@
                         <a:defRPr sz="1300"/>
                       </a:pPr>
                       <a:r>
-                        <a:t>+0.014</a:t>
+                        <a:t>+0.019  p=0.006</a:t>
                       </a:r>
                     </a:p>
                   </a:txBody>
@@ -4791,7 +4939,7 @@
                         <a:defRPr sz="1300"/>
                       </a:pPr>
                       <a:r>
-                        <a:t>same change on a second architecture</a:t>
+                        <a:t>same change, published simplicial model (32 seeds)</a:t>
                       </a:r>
                     </a:p>
                   </a:txBody>
@@ -4806,7 +4954,7 @@
                         <a:defRPr sz="1300"/>
                       </a:pPr>
                       <a:r>
-                        <a:t>+0.015</a:t>
+                        <a:t>+0.017  p=0.003</a:t>
                       </a:r>
                     </a:p>
                   </a:txBody>
@@ -4850,7 +4998,7 @@
               </a:defRPr>
             </a:pPr>
             <a:r>
-              <a:t>Every structure-side improvement left the score unchanged or worse; every surviving gain came from aligning the training loss with the scored separation.</a:t>
+              <a:t>Every structure-side improvement left the score unchanged or worse; every surviving gain came from aligning the training loss with the scored separation — the same change, on both encoders, from disjoint seed sets, passing the anti-calibration check (pre-registered).</a:t>
             </a:r>
           </a:p>
           <a:p>
@@ -4878,7 +5026,7 @@
 </p:sld>
 </file>
 
-<file path=ppt/slides/slide12.xml><?xml version="1.0" encoding="utf-8"?>
+<file path=ppt/slides/slide13.xml><?xml version="1.0" encoding="utf-8"?>
 <p:sld xmlns:a="http://schemas.openxmlformats.org/drawingml/2006/main" xmlns:p="http://schemas.openxmlformats.org/presentationml/2006/main" xmlns:r="http://schemas.openxmlformats.org/officeDocument/2006/relationships">
   <p:cSld>
     <p:spTree>
@@ -4956,7 +5104,7 @@
               </a:defRPr>
             </a:pPr>
             <a:r>
-              <a:t>1.  The best system includes the 3D structure model: 0.313 vs 0.291 without it, largest fitted weight. Its contribution is correcting errors the conventional models share — and it is not reproducible by handing the trees 3D-derived descriptors.</a:t>
+              <a:t>1.  The best system includes the 3D structure model: 0.313 vs 0.291 without it, largest fitted weight — and its contribution is not reproducible by handing the trees 3D-derived descriptors (those collapse the model).</a:t>
             </a:r>
           </a:p>
           <a:p>
@@ -4971,7 +5119,7 @@
               </a:defRPr>
             </a:pPr>
             <a:r>
-              <a:t>2.  The ceiling on 3D is the quantum chemistry: GFN2-xTB carries no f-shell physics and under-responds to the lanthanide contraction 2.5×. Fixing the chemistry (g-xTB: right to within 8 %, 71/71 ligands, p = 5×10⁻⁵²) does not move the prediction — a new, standalone benchmark result.</a:t>
+              <a:t>2.  The ceiling on 3D is the quantum chemistry: GFN2-xTB carries no f-shell physics and under-responds to the lanthanide contraction 2.5×. Fixing the chemistry (g-xTB: within 8 %, 71/71 ligands, p = 5×10⁻⁵²) does not move the prediction — a new, standalone benchmark result.</a:t>
             </a:r>
           </a:p>
           <a:p>
@@ -4986,7 +5134,7 @@
               </a:defRPr>
             </a:pPr>
             <a:r>
-              <a:t>3.  What moved predictions, every time, was aligning the training loss with the scored separation — not richer structures.</a:t>
+              <a:t>3.  What moved predictions was aligning the training loss with the scored separation — the one fully pre-registered positive: +0.019 / +0.017 on the two encoders, 32 disjoint seeds each, both passing the anti-calibration check.</a:t>
             </a:r>
           </a:p>
           <a:p>
@@ -5013,7 +5161,7 @@
               </a:defRPr>
             </a:pPr>
             <a:r>
-              <a:t>Next: a fresh held-out split to confirm 0.313; the contraction benchmark as a paper (adding Ln-xTB, Zhang 2026); predicting separations directly, toward the 0.53 that the labels support.</a:t>
+              <a:t>Next: a fresh held-out split to confirm 0.313; the contraction benchmark as a paper (add Ln-xTB, Zhang 2026); predicting separations directly, toward the 0.53 the labels support.</a:t>
             </a:r>
           </a:p>
         </p:txBody>
@@ -5141,7 +5289,7 @@
         <p:spPr>
           <a:xfrm>
             <a:off x="1158087" y="2880360"/>
-            <a:ext cx="9875520" cy="3103734"/>
+            <a:ext cx="9875520" cy="3545157"/>
           </a:xfrm>
           <a:prstGeom prst="rect">
             <a:avLst/>
@@ -5595,8 +5743,8 @@
         </p:blipFill>
         <p:spPr>
           <a:xfrm>
-            <a:off x="929487" y="1280160"/>
-            <a:ext cx="10332720" cy="3731260"/>
+            <a:off x="1249527" y="1234440"/>
+            <a:ext cx="9692640" cy="5755005"/>
           </a:xfrm>
           <a:prstGeom prst="rect">
             <a:avLst/>
@@ -5719,7 +5867,7 @@
               </a:defRPr>
             </a:pPr>
             <a:r>
-              <a:t>Model 3 — a network that reads the optimised 3D structure of the extraction complex itself (next slide).</a:t>
+              <a:t>Model 3 — a network that reads the optimised 3D structure of the extraction complex itself (next slides).</a:t>
             </a:r>
           </a:p>
           <a:p>
@@ -5746,7 +5894,7 @@
               </a:defRPr>
             </a:pPr>
             <a:r>
-              <a:t>Each predicts log D per measurement; separations are differences of predictions inside a block. The final system is a weighted combination of the three, with weights fitted per held-out extractant on the separations directly.</a:t>
+              <a:t>Each predicts log D per measurement; separations are differences of predictions inside a block. The final system is a weighted combination of the three, weights fitted per held-out extractant on the separations directly.</a:t>
             </a:r>
           </a:p>
         </p:txBody>
@@ -5821,51 +5969,13 @@
         <p:spPr>
           <a:xfrm>
             <a:off x="518007" y="1325880"/>
-            <a:ext cx="11155680" cy="3098800"/>
+            <a:ext cx="11155680" cy="5316378"/>
           </a:xfrm>
           <a:prstGeom prst="rect">
             <a:avLst/>
           </a:prstGeom>
         </p:spPr>
       </p:pic>
-      <p:sp>
-        <p:nvSpPr>
-          <p:cNvPr id="4" name="TextBox 3"/>
-          <p:cNvSpPr txBox="1"/>
-          <p:nvPr/>
-        </p:nvSpPr>
-        <p:spPr>
-          <a:xfrm>
-            <a:off x="548640" y="5029200"/>
-            <a:ext cx="11064240" cy="1645919"/>
-          </a:xfrm>
-          <a:prstGeom prst="rect">
-            <a:avLst/>
-          </a:prstGeom>
-          <a:noFill/>
-        </p:spPr>
-        <p:txBody>
-          <a:bodyPr wrap="square">
-            <a:spAutoFit/>
-          </a:bodyPr>
-          <a:lstStyle/>
-          <a:p>
-            <a:pPr>
-              <a:spcAft>
-                <a:spcPts val="700"/>
-              </a:spcAft>
-              <a:defRPr sz="1350">
-                <a:solidFill>
-                  <a:srgbClr val="101214"/>
-                </a:solidFill>
-              </a:defRPr>
-            </a:pPr>
-            <a:r>
-              <a:t>The network never sees raw coordinates — only this mesh and per-atom features. Pooling is centred on the metal, as a histogram over distance shells, so sub-0.1 Å changes in the coordination shell survive averaging.</a:t>
-            </a:r>
-          </a:p>
-        </p:txBody>
-      </p:sp>
     </p:spTree>
   </p:cSld>
   <p:clrMapOvr>
@@ -5875,6 +5985,83 @@
 </file>
 
 <file path=ppt/slides/slide7.xml><?xml version="1.0" encoding="utf-8"?>
+<p:sld xmlns:a="http://schemas.openxmlformats.org/drawingml/2006/main" xmlns:p="http://schemas.openxmlformats.org/presentationml/2006/main" xmlns:r="http://schemas.openxmlformats.org/officeDocument/2006/relationships">
+  <p:cSld>
+    <p:spTree>
+      <p:nvGrpSpPr>
+        <p:cNvPr id="1" name=""/>
+        <p:cNvGrpSpPr/>
+        <p:nvPr/>
+      </p:nvGrpSpPr>
+      <p:grpSpPr/>
+      <p:sp>
+        <p:nvSpPr>
+          <p:cNvPr id="2" name="TextBox 1"/>
+          <p:cNvSpPr txBox="1"/>
+          <p:nvPr/>
+        </p:nvSpPr>
+        <p:spPr>
+          <a:xfrm>
+            <a:off x="502920" y="292608"/>
+            <a:ext cx="11247120" cy="640080"/>
+          </a:xfrm>
+          <a:prstGeom prst="rect">
+            <a:avLst/>
+          </a:prstGeom>
+          <a:noFill/>
+        </p:spPr>
+        <p:txBody>
+          <a:bodyPr wrap="none">
+            <a:spAutoFit/>
+          </a:bodyPr>
+          <a:lstStyle/>
+          <a:p>
+            <a:pPr>
+              <a:defRPr sz="2600" b="1">
+                <a:solidFill>
+                  <a:srgbClr val="1A2E4A"/>
+                </a:solidFill>
+              </a:defRPr>
+            </a:pPr>
+            <a:r>
+              <a:t>From structure to a number</a:t>
+            </a:r>
+          </a:p>
+        </p:txBody>
+      </p:sp>
+      <p:pic>
+        <p:nvPicPr>
+          <p:cNvPr id="3" name="Picture 2" descr="g6_vector.png"/>
+          <p:cNvPicPr>
+            <a:picLocks noChangeAspect="1"/>
+          </p:cNvPicPr>
+          <p:nvPr/>
+        </p:nvPicPr>
+        <p:blipFill>
+          <a:blip r:embed="rId3"/>
+          <a:stretch>
+            <a:fillRect/>
+          </a:stretch>
+        </p:blipFill>
+        <p:spPr>
+          <a:xfrm>
+            <a:off x="655167" y="1234440"/>
+            <a:ext cx="10881360" cy="5610701"/>
+          </a:xfrm>
+          <a:prstGeom prst="rect">
+            <a:avLst/>
+          </a:prstGeom>
+        </p:spPr>
+      </p:pic>
+    </p:spTree>
+  </p:cSld>
+  <p:clrMapOvr>
+    <a:masterClrMapping/>
+  </p:clrMapOvr>
+</p:sld>
+</file>
+
+<file path=ppt/slides/slide8.xml><?xml version="1.0" encoding="utf-8"?>
 <p:sld xmlns:a="http://schemas.openxmlformats.org/drawingml/2006/main" xmlns:p="http://schemas.openxmlformats.org/presentationml/2006/main" xmlns:r="http://schemas.openxmlformats.org/officeDocument/2006/relationships">
   <p:cSld>
     <p:spTree>
@@ -6055,7 +6242,7 @@
                         <a:defRPr sz="1400"/>
                       </a:pPr>
                       <a:r>
-                        <a:t>3D structure model</a:t>
+                        <a:t>best 3D structure model</a:t>
                       </a:r>
                     </a:p>
                   </a:txBody>
@@ -6210,7 +6397,7 @@
               </a:defRPr>
             </a:pPr>
             <a:r>
-              <a:t>The 3D model adds +0.023 to the best conventional combination and carries the largest fitted weight (0.46). Its value is correcting errors the other two share — handing the same 3D information to the trees as descriptors does not reproduce it.</a:t>
+              <a:t>The 3D model adds +0.023 to the best conventional combination and carries the largest fitted weight (0.46). Handing the same 3D information to the trees as descriptors does not reproduce it — it subtracts.</a:t>
             </a:r>
           </a:p>
           <a:p>
@@ -6226,136 +6413,6 @@
             </a:pPr>
             <a:r>
               <a:t>Under stricter condition blocking the margin is +0.010; the 0.313 is exploratory until confirmed on a fresh held-out split.</a:t>
-            </a:r>
-          </a:p>
-        </p:txBody>
-      </p:sp>
-    </p:spTree>
-  </p:cSld>
-  <p:clrMapOvr>
-    <a:masterClrMapping/>
-  </p:clrMapOvr>
-</p:sld>
-</file>
-
-<file path=ppt/slides/slide8.xml><?xml version="1.0" encoding="utf-8"?>
-<p:sld xmlns:a="http://schemas.openxmlformats.org/drawingml/2006/main" xmlns:p="http://schemas.openxmlformats.org/presentationml/2006/main" xmlns:r="http://schemas.openxmlformats.org/officeDocument/2006/relationships">
-  <p:cSld>
-    <p:spTree>
-      <p:nvGrpSpPr>
-        <p:cNvPr id="1" name=""/>
-        <p:cNvGrpSpPr/>
-        <p:nvPr/>
-      </p:nvGrpSpPr>
-      <p:grpSpPr/>
-      <p:sp>
-        <p:nvSpPr>
-          <p:cNvPr id="2" name="TextBox 1"/>
-          <p:cNvSpPr txBox="1"/>
-          <p:nvPr/>
-        </p:nvSpPr>
-        <p:spPr>
-          <a:xfrm>
-            <a:off x="502920" y="292608"/>
-            <a:ext cx="11247120" cy="640080"/>
-          </a:xfrm>
-          <a:prstGeom prst="rect">
-            <a:avLst/>
-          </a:prstGeom>
-          <a:noFill/>
-        </p:spPr>
-        <p:txBody>
-          <a:bodyPr wrap="none">
-            <a:spAutoFit/>
-          </a:bodyPr>
-          <a:lstStyle/>
-          <a:p>
-            <a:pPr>
-              <a:defRPr sz="2600" b="1">
-                <a:solidFill>
-                  <a:srgbClr val="1A2E4A"/>
-                </a:solidFill>
-              </a:defRPr>
-            </a:pPr>
-            <a:r>
-              <a:t>Why the 3D signal is capped: the quantum chemistry underneath</a:t>
-            </a:r>
-          </a:p>
-        </p:txBody>
-      </p:sp>
-      <p:pic>
-        <p:nvPicPr>
-          <p:cNvPr id="3" name="Picture 2" descr="g4_params.png"/>
-          <p:cNvPicPr>
-            <a:picLocks noChangeAspect="1"/>
-          </p:cNvPicPr>
-          <p:nvPr/>
-        </p:nvPicPr>
-        <p:blipFill>
-          <a:blip r:embed="rId3"/>
-          <a:stretch>
-            <a:fillRect/>
-          </a:stretch>
-        </p:blipFill>
-        <p:spPr>
-          <a:xfrm>
-            <a:off x="975207" y="1280160"/>
-            <a:ext cx="10241280" cy="3037667"/>
-          </a:xfrm>
-          <a:prstGeom prst="rect">
-            <a:avLst/>
-          </a:prstGeom>
-        </p:spPr>
-      </p:pic>
-      <p:sp>
-        <p:nvSpPr>
-          <p:cNvPr id="4" name="TextBox 3"/>
-          <p:cNvSpPr txBox="1"/>
-          <p:nvPr/>
-        </p:nvSpPr>
-        <p:spPr>
-          <a:xfrm>
-            <a:off x="548640" y="4480560"/>
-            <a:ext cx="11064240" cy="2194559"/>
-          </a:xfrm>
-          <a:prstGeom prst="rect">
-            <a:avLst/>
-          </a:prstGeom>
-          <a:noFill/>
-        </p:spPr>
-        <p:txBody>
-          <a:bodyPr wrap="square">
-            <a:spAutoFit/>
-          </a:bodyPr>
-          <a:lstStyle/>
-          <a:p>
-            <a:pPr>
-              <a:spcAft>
-                <a:spcPts val="700"/>
-              </a:spcAft>
-              <a:defRPr sz="1350">
-                <a:solidFill>
-                  <a:srgbClr val="101214"/>
-                </a:solidFill>
-              </a:defRPr>
-            </a:pPr>
-            <a:r>
-              <a:t>To GFN2-xTB, the identity of the lanthanide is one number on a straight line. Its structures can therefore carry no f-shell physics — and that one number is already a descriptor column (the experimental ionic radius).</a:t>
-            </a:r>
-          </a:p>
-          <a:p>
-            <a:pPr>
-              <a:spcAft>
-                <a:spcPts val="700"/>
-              </a:spcAft>
-              <a:defRPr sz="1350">
-                <a:solidFill>
-                  <a:srgbClr val="101214"/>
-                </a:solidFill>
-              </a:defRPr>
-            </a:pPr>
-            <a:r>
-              <a:t>Checked empirically: eight different 3D architectures give statistically identical predictions (cross-architecture correlation 0.986 — the same as re-running one architecture with a different random start).</a:t>
             </a:r>
           </a:p>
         </p:txBody>
@@ -6408,14 +6465,14 @@
               </a:defRPr>
             </a:pPr>
             <a:r>
-              <a:t>Measuring what the structures get wrong: the contraction response</a:t>
+              <a:t>Why the 3D signal is capped: the quantum chemistry underneath</a:t>
             </a:r>
           </a:p>
         </p:txBody>
       </p:sp>
       <p:pic>
         <p:nvPicPr>
-          <p:cNvPr id="3" name="Picture 2" descr="g5_slope_demo.png"/>
+          <p:cNvPr id="3" name="Picture 2" descr="g4_params.png"/>
           <p:cNvPicPr>
             <a:picLocks noChangeAspect="1"/>
           </p:cNvPicPr>
@@ -6429,8 +6486,8 @@
         </p:blipFill>
         <p:spPr>
           <a:xfrm>
-            <a:off x="2346807" y="1280160"/>
-            <a:ext cx="7498079" cy="4143675"/>
+            <a:off x="792327" y="1280160"/>
+            <a:ext cx="10607040" cy="4806315"/>
           </a:xfrm>
           <a:prstGeom prst="rect">
             <a:avLst/>
@@ -6445,8 +6502,8 @@
         </p:nvSpPr>
         <p:spPr>
           <a:xfrm>
-            <a:off x="548640" y="5257800"/>
-            <a:ext cx="11064240" cy="1417319"/>
+            <a:off x="548640" y="4892040"/>
+            <a:ext cx="11064240" cy="1783080"/>
           </a:xfrm>
           <a:prstGeom prst="rect">
             <a:avLst/>
@@ -6470,7 +6527,7 @@
               </a:defRPr>
             </a:pPr>
             <a:r>
-              <a:t>Swap the metal inside a fixed ligand cage, re-relax, and ask: does the metal–donor bond shrink as much as the ion actually shrinks? The slope of this line is the structure's response to the lanthanide contraction — the physics adjacent-pair selectivity runs on.</a:t>
+              <a:t>To GFN2-xTB, lanthanide identity is one number on a straight line — and that number is already a descriptor column (the Shannon ionic radius). Eight different 3D architectures give statistically identical predictions (correlation 0.986 = seed noise).</a:t>
             </a:r>
           </a:p>
         </p:txBody>

</xml_diff>